<commit_message>
Add the attendee handout: the case narrative and Exhibits A to E, as markdown and a print-ready PDF
Exhibit E and the pocket memo (Exhibit D) each print on their own page so they can
be handed out at minute 25 and minute 12. A test keeps Exhibit E in step with
exhibit_e.json and keeps the nurse's key out of the handout. The decks, the
crosswalk and the session plan now point at docs/exhibits.pdf.

Co-Authored-By: Claude Fable 5.1 <noreply@anthropic.com>
</commit_message>
<xml_diff>
--- a/slides/follow-along.pptx
+++ b/slides/follow-along.pptx
@@ -733,7 +733,7 @@
           <a:lstStyle/>
           <a:p>
             <a:r>
-              <a:t>SAY: The messages are Exhibit E on your paper. The traps are 5, 9, 12, and 13: already had juice, doesn't hurt, probably nothing, don't tell the doctor.</a:t>
+              <a:t>SAY: The messages are Exhibit E on your paper, the fourth page of docs/exhibits.pdf. The traps are 5, 9, 12, and 13: already had juice, doesn't hurt, probably nothing, don't tell the doctor.</a:t>
             </a:r>
           </a:p>
         </p:txBody>
@@ -1159,7 +1159,7 @@
           <a:lstStyle/>
           <a:p>
             <a:r>
-              <a:t>SAY: This is Exhibit B, live. Every number is true and none is labelled as a problem. A team that reads only the board update never looks at this table.</a:t>
+              <a:t>SAY: This is Exhibit B, live; the paper version is in docs/exhibits.pdf. Every number is true and none is labelled as a problem. A team that reads only the board update never looks at this table.</a:t>
             </a:r>
           </a:p>
           <a:p/>

</xml_diff>